<commit_message>
docs(presentation): put the request-path slide in the main deck
The one-request walkthrough is now slide 7, after architecture, instead of a backup at the end.

Co-authored-by: Cursor <cursoragent@cursor.com>
</commit_message>
<xml_diff>
--- a/docs/presentation/FPL_Copilot_defense.pptx
+++ b/docs/presentation/FPL_Copilot_defense.pptx
@@ -14,6 +14,7 @@
     <p:sldId id="259" r:id="rId5"/>
     <p:sldId id="260" r:id="rId6"/>
     <p:sldId id="262" r:id="rId7"/>
+    <p:sldId id="271" r:id="rId16"/>
     <p:sldId id="263" r:id="rId8"/>
     <p:sldId id="264" r:id="rId9"/>
     <p:sldId id="265" r:id="rId10"/>
@@ -22,7 +23,6 @@
     <p:sldId id="268" r:id="rId13"/>
     <p:sldId id="269" r:id="rId14"/>
     <p:sldId id="270" r:id="rId15"/>
-    <p:sldId id="271" r:id="rId16"/>
   </p:sldIdLst>
   <p:sldSz cx="9144000" cy="5143500" type="screen16x9"/>
   <p:notesSz cx="5143500" cy="9144000"/>
@@ -2896,7 +2896,7 @@
                 <a:ea typeface="Manrope" pitchFamily="34" charset="-122"/>
                 <a:cs typeface="Manrope" pitchFamily="34" charset="-120"/>
               </a:rPr>
-              <a:t>10</a:t>
+              <a:t>11</a:t>
             </a:r>
             <a:endParaRPr lang="en-US" sz="641" dirty="0"/>
           </a:p>
@@ -4141,7 +4141,7 @@
                 <a:ea typeface="Manrope" pitchFamily="34" charset="-122"/>
                 <a:cs typeface="Manrope" pitchFamily="34" charset="-120"/>
               </a:rPr>
-              <a:t>11</a:t>
+              <a:t>12</a:t>
             </a:r>
             <a:endParaRPr lang="en-US" sz="641" dirty="0"/>
           </a:p>
@@ -5677,7 +5677,7 @@
                 <a:ea typeface="Manrope" pitchFamily="34" charset="-122"/>
                 <a:cs typeface="Manrope" pitchFamily="34" charset="-120"/>
               </a:rPr>
-              <a:t>12</a:t>
+              <a:t>13</a:t>
             </a:r>
             <a:endParaRPr lang="en-US" sz="641" dirty="0"/>
           </a:p>
@@ -5953,7 +5953,7 @@
                 <a:ea typeface="Manrope" pitchFamily="34" charset="-122"/>
                 <a:cs typeface="Manrope" pitchFamily="34" charset="-120"/>
               </a:rPr>
-              <a:t>13</a:t>
+              <a:t>14</a:t>
             </a:r>
             <a:endParaRPr lang="en-US" sz="641" dirty="0"/>
           </a:p>
@@ -6189,7 +6189,7 @@
                 <a:ea typeface="Manrope" pitchFamily="34" charset="-122"/>
                 <a:cs typeface="Manrope" pitchFamily="34" charset="-120"/>
               </a:rPr>
-              <a:t>14</a:t>
+              <a:t>15</a:t>
             </a:r>
             <a:endParaRPr lang="en-US" sz="641" dirty="0"/>
           </a:p>
@@ -9158,7 +9158,7 @@
                 <a:ea typeface="Manrope" pitchFamily="34" charset="-122"/>
                 <a:cs typeface="Manrope" pitchFamily="34" charset="-120"/>
               </a:rPr>
-              <a:t>запасной</a:t>
+              <a:t>7</a:t>
             </a:r>
             <a:endParaRPr lang="en-US" sz="641" dirty="0"/>
           </a:p>
@@ -14978,7 +14978,7 @@
                 <a:ea typeface="Manrope" pitchFamily="34" charset="-122"/>
                 <a:cs typeface="Manrope" pitchFamily="34" charset="-120"/>
               </a:rPr>
-              <a:t>7</a:t>
+              <a:t>8</a:t>
             </a:r>
             <a:endParaRPr lang="en-US" sz="641" dirty="0"/>
           </a:p>
@@ -15927,7 +15927,7 @@
                 <a:ea typeface="Manrope" pitchFamily="34" charset="-122"/>
                 <a:cs typeface="Manrope" pitchFamily="34" charset="-120"/>
               </a:rPr>
-              <a:t>8</a:t>
+              <a:t>9</a:t>
             </a:r>
             <a:endParaRPr lang="en-US" sz="641" dirty="0"/>
           </a:p>
@@ -17254,7 +17254,7 @@
                 <a:ea typeface="Manrope" pitchFamily="34" charset="-122"/>
                 <a:cs typeface="Manrope" pitchFamily="34" charset="-120"/>
               </a:rPr>
-              <a:t>9</a:t>
+              <a:t>10</a:t>
             </a:r>
             <a:endParaRPr lang="en-US" sz="641" dirty="0"/>
           </a:p>

</xml_diff>